<commit_message>
Updated PPT and UI/UX
</commit_message>
<xml_diff>
--- a/docs/TraceHold-Pitch-Deck.pptx
+++ b/docs/TraceHold-Pitch-Deck.pptx
@@ -124,19 +124,19 @@
   <p:extLst>
     <p:ext uri="{521415D9-36F7-43E2-AB2F-B90AF26B5E84}">
       <p14:sectionLst xmlns:p14="http://schemas.microsoft.com/office/powerpoint/2010/main">
-        <p14:section name="Opening" id="{39713b62-0610-2b04-d155-38b9338ddd60}">
+        <p14:section name="Opening" id="{8226d28d-07d9-cdfb-ea8c-03247187009c}">
           <p14:sldIdLst>
             <p14:sldId id="256"/>
           </p14:sldIdLst>
         </p14:section>
-        <p14:section name="Problem" id="{2dd3b46a-d1a0-64b1-f985-aa1c97fc0f3e}">
+        <p14:section name="Problem" id="{6e9975c8-a8e8-419e-10b8-ce342732e2ac}">
           <p14:sldIdLst>
             <p14:sldId id="257"/>
             <p14:sldId id="258"/>
             <p14:sldId id="259"/>
           </p14:sldIdLst>
         </p14:section>
-        <p14:section name="Solution" id="{69739398-3eb6-37b6-d88d-b83172ffa21f}">
+        <p14:section name="Solution" id="{d5154ce9-11b4-e6fb-4259-97d20c7cba82}">
           <p14:sldIdLst>
             <p14:sldId id="260"/>
             <p14:sldId id="261"/>
@@ -144,26 +144,26 @@
             <p14:sldId id="263"/>
           </p14:sldIdLst>
         </p14:section>
-        <p14:section name="Exasol" id="{16a5c8cb-eb17-38a0-1fba-a9b11df5499a}">
+        <p14:section name="Exasol" id="{85dd1bfe-3f00-a5e5-3cf8-6bbae3eb252c}">
           <p14:sldIdLst>
             <p14:sldId id="264"/>
             <p14:sldId id="265"/>
           </p14:sldIdLst>
         </p14:section>
-        <p14:section name="Trust" id="{701bb516-9aab-0b93-f118-bc9001f15166}">
+        <p14:section name="Trust" id="{9f7cc6a2-f387-c635-a29f-b6b2691e9ae6}">
           <p14:sldIdLst>
             <p14:sldId id="266"/>
             <p14:sldId id="267"/>
             <p14:sldId id="268"/>
           </p14:sldIdLst>
         </p14:section>
-        <p14:section name="Positioning" id="{2ff93780-d0fb-a104-da8a-7a832c30a54d}">
+        <p14:section name="Positioning" id="{b2213753-93da-8eae-5fc9-7a1de9bec397}">
           <p14:sldIdLst>
             <p14:sldId id="269"/>
             <p14:sldId id="270"/>
           </p14:sldIdLst>
         </p14:section>
-        <p14:section name="Closing" id="{06e342fb-66a0-3891-6c8f-6a5ae1cbfd22}">
+        <p14:section name="Closing" id="{2b9bf535-2ca2-29f5-a227-9f39e24f3d4c}">
           <p14:sldIdLst>
             <p14:sldId id="271"/>
             <p14:sldId id="272"/>
@@ -5895,7 +5895,7 @@
       </p:sp>
       <p:pic>
         <p:nvPicPr>
-          <p:cNvPr id="4" name="try to break it screenshot" descr="C:\Users\lisam\Projects\LienLens\docs\screenshots\08-try-to-break-it.jpg">    </p:cNvPr>
+          <p:cNvPr id="4" name="try to break it screenshot" descr="C:\Users\lisam\Projects\LienLens\docs\screenshots\05-try-to-break-it.jpg">    </p:cNvPr>
           <p:cNvPicPr>
             <a:picLocks noChangeAspect="1"/>
           </p:cNvPicPr>
@@ -12102,7 +12102,7 @@
                 <a:ea typeface="Calibri" pitchFamily="34" charset="-122"/>
                 <a:cs typeface="Calibri" pitchFamily="34" charset="-120"/>
               </a:rPr>
-              <a:t>47 tests, 53 browser checks, WCAG AA checked</a:t>
+              <a:t>47 tests, 54 browser checks, WCAG AA checked</a:t>
             </a:r>
             <a:endParaRPr lang="en-US" sz="1400" dirty="0"/>
           </a:p>
@@ -16957,7 +16957,7 @@
                 <a:ea typeface="Calibri" pitchFamily="34" charset="-122"/>
                 <a:cs typeface="Calibri" pitchFamily="34" charset="-120"/>
               </a:rPr>
-              <a:t>Checklist from court directions; AI reads free-text letters, rules verify every field (CF1, CF9)</a:t>
+              <a:t>Checklist from court directions; AI reads free-text letters, rules verify every field</a:t>
             </a:r>
             <a:endParaRPr lang="en-US" sz="1400" dirty="0"/>
           </a:p>
@@ -17150,7 +17150,7 @@
                 <a:ea typeface="Calibri" pitchFamily="34" charset="-122"/>
                 <a:cs typeface="Calibri" pitchFamily="34" charset="-120"/>
               </a:rPr>
-              <a:t>Hop by hop, through splits, merges, loops, reversals, duplicates and clock skew (CF2)</a:t>
+              <a:t>Hop by hop, through splits, merges, loops, reversals, duplicates and clock skew</a:t>
             </a:r>
             <a:endParaRPr lang="en-US" sz="1400" dirty="0"/>
           </a:p>
@@ -17343,7 +17343,7 @@
                 <a:ea typeface="Calibri" pitchFamily="34" charset="-122"/>
                 <a:cs typeface="Calibri" pitchFamily="34" charset="-120"/>
               </a:rPr>
-              <a:t>Pro-rata and FIFO ranges, traceable share, status; abstains when records are missing (CF3, CF4, CF6)</a:t>
+              <a:t>Pro-rata and FIFO ranges, traceable share, status; abstains when records are missing</a:t>
             </a:r>
             <a:endParaRPr lang="en-US" sz="1400" dirty="0"/>
           </a:p>
@@ -17536,7 +17536,7 @@
                 <a:ea typeface="Calibri" pitchFamily="34" charset="-122"/>
                 <a:cs typeface="Calibri" pitchFamily="34" charset="-120"/>
               </a:rPr>
-              <a:t>Within evidence, within range, exceeds evidence, or cannot determine (CF5)</a:t>
+              <a:t>Within evidence, within range, exceeds evidence, or cannot determine</a:t>
             </a:r>
             <a:endParaRPr lang="en-US" sz="1400" dirty="0"/>
           </a:p>
@@ -17729,7 +17729,7 @@
                 <a:ea typeface="Calibri" pitchFamily="34" charset="-122"/>
                 <a:cs typeface="Calibri" pitchFamily="34" charset="-120"/>
               </a:rPr>
-              <a:t>Evidence packet, plain-language letter, proportionate hold, forwarded requests (CF7, CF8)</a:t>
+              <a:t>Evidence packet, plain-language letter, proportionate hold, forwarded requests</a:t>
             </a:r>
             <a:endParaRPr lang="en-US" sz="1400" dirty="0"/>
           </a:p>
@@ -18406,7 +18406,7 @@
                 <a:ea typeface="Calibri" pitchFamily="34" charset="-122"/>
                 <a:cs typeface="Calibri" pitchFamily="34" charset="-120"/>
               </a:rPr>
-              <a:t>Existing holds ranked for a person: over-held, closed but still frozen, past 90 days, no update (AF1, AF5).</a:t>
+              <a:t>Existing holds ranked for a person: over-held, closed but still frozen, past 90 days, no update.</a:t>
             </a:r>
             <a:endParaRPr lang="en-US" sz="1300" dirty="0"/>
           </a:p>
@@ -18560,7 +18560,7 @@
                 <a:ea typeface="Calibri" pitchFamily="34" charset="-122"/>
                 <a:cs typeface="Calibri" pitchFamily="34" charset="-120"/>
               </a:rPr>
-              <a:t>Plain-English questions answered through Exasol's MCP server; the SQL and rows are always shown (AF7).</a:t>
+              <a:t>Plain-English questions answered through Exasol's MCP server; the SQL and rows are always shown.</a:t>
             </a:r>
             <a:endParaRPr lang="en-US" sz="1300" dirty="0"/>
           </a:p>
@@ -18868,7 +18868,7 @@
                 <a:ea typeface="Calibri" pitchFamily="34" charset="-122"/>
                 <a:cs typeface="Calibri" pitchFamily="34" charset="-120"/>
               </a:rPr>
-              <a:t>Evidence packet citing every transaction, and a neutral letter for the account holder (CF7, AF8).</a:t>
+              <a:t>Evidence packet citing every transaction, and a neutral letter for the account holder.</a:t>
             </a:r>
             <a:endParaRPr lang="en-US" sz="1300" dirty="0"/>
           </a:p>

</xml_diff>